<commit_message>
docs: fix Slide 4 architecture diagram aspect ratio in PPTX
</commit_message>
<xml_diff>
--- a/docs/phase5/presentation.pptx
+++ b/docs/phase5/presentation.pptx
@@ -4374,8 +4374,8 @@
         </p:blipFill>
         <p:spPr>
           <a:xfrm>
-            <a:off x="1097280" y="1280160"/>
-            <a:ext cx="6949440" cy="3200400"/>
+            <a:off x="2834640" y="1188720"/>
+            <a:ext cx="3474720" cy="3474720"/>
           </a:xfrm>
           <a:prstGeom prst="rect">
             <a:avLst/>

</xml_diff>